<commit_message>
fix: DPO 쌍 분포 표 불완전 수정 — onpolicy(228)·refusal(200) 누락 보완
슬라이드 6과 format_spec.md의 위반 유형 표가 6개 카테고리(합 940)만 표시해
전체 1,368쌍의 69%만 노출. 누락분 보완해 합계 1,368에 일치시킴:
- onpolicy 228쌍 추가 (2번째로 큰 카테고리, 체인 154 등)
- refusal(거절) 200쌍 추가 (category=NaN, refusal_v2/*)
- 합계 행 추가로 검산 가능하게

개별 수치는 모두 정확했으나 표가 불완전해 '전부'처럼 오인될 소지 제거.

Co-Authored-By: Claude Opus 4.8 <noreply@anthropic.com>
</commit_message>
<xml_diff>
--- a/presentation/TimeSorter_발표자료.pptx
+++ b/presentation/TimeSorter_발표자료.pptx
@@ -10557,7 +10557,7 @@
         </p:nvSpPr>
         <p:spPr>
           <a:xfrm>
-            <a:off x="457200" y="3977639"/>
+            <a:off x="457200" y="3931920"/>
             <a:ext cx="10972800" cy="365760"/>
           </a:xfrm>
           <a:prstGeom prst="rect">
@@ -10579,7 +10579,7 @@
                 </a:solidFill>
                 <a:latin typeface="Noto Sans CJK KR"/>
               </a:rPr>
-              <a:t>DPO rejected 위반 유형 분포 (v5)</a:t>
+              <a:t>DPO 쌍 구성 (v5, 총 1,368쌍)</a:t>
             </a:r>
           </a:p>
         </p:txBody>
@@ -10593,8 +10593,8 @@
           <p:nvPr/>
         </p:nvGraphicFramePr>
         <p:xfrm>
-          <a:off x="457200" y="4389120"/>
-          <a:ext cx="11292840" cy="1737360"/>
+          <a:off x="457200" y="4315968"/>
+          <a:ext cx="11292840" cy="1828800"/>
         </p:xfrm>
         <a:graphic>
           <a:graphicData uri="http://schemas.openxmlformats.org/drawingml/2006/table">
@@ -10607,7 +10607,7 @@
                 <a:gridCol w="1645920"/>
                 <a:gridCol w="5715000"/>
               </a:tblGrid>
-              <a:tr h="289560">
+              <a:tr h="203200">
                 <a:tc>
                   <a:txBody>
                     <a:bodyPr wrap="square"/>
@@ -10678,7 +10678,7 @@
                   </a:tcPr>
                 </a:tc>
               </a:tr>
-              <a:tr h="289560">
+              <a:tr h="203200">
                 <a:tc>
                   <a:txBody>
                     <a:bodyPr wrap="square"/>
@@ -10686,7 +10686,7 @@
                     <a:p>
                       <a:pPr algn="l"/>
                       <a:r>
-                        <a:rPr sz="1200" b="0" i="0">
+                        <a:rPr sz="1100" b="0" i="0">
                           <a:solidFill>
                             <a:srgbClr val="222222"/>
                           </a:solidFill>
@@ -10709,7 +10709,7 @@
                     <a:p>
                       <a:pPr algn="ctr"/>
                       <a:r>
-                        <a:rPr sz="1200" b="0" i="0">
+                        <a:rPr sz="1100" b="0" i="0">
                           <a:solidFill>
                             <a:srgbClr val="222222"/>
                           </a:solidFill>
@@ -10732,7 +10732,7 @@
                     <a:p>
                       <a:pPr algn="ctr"/>
                       <a:r>
-                        <a:rPr sz="1200" b="0" i="0">
+                        <a:rPr sz="1100" b="0" i="0">
                           <a:solidFill>
                             <a:srgbClr val="222222"/>
                           </a:solidFill>
@@ -10749,7 +10749,7 @@
                   </a:tcPr>
                 </a:tc>
               </a:tr>
-              <a:tr h="289560">
+              <a:tr h="203200">
                 <a:tc>
                   <a:txBody>
                     <a:bodyPr wrap="square"/>
@@ -10757,13 +10757,13 @@
                     <a:p>
                       <a:pPr algn="l"/>
                       <a:r>
-                        <a:rPr sz="1200" b="0" i="0">
+                        <a:rPr sz="1100" b="0" i="0">
                           <a:solidFill>
                             <a:srgbClr val="222222"/>
                           </a:solidFill>
                           <a:latin typeface="Noto Sans CJK KR"/>
                         </a:rPr>
-                        <a:t>granularity_swap</a:t>
+                        <a:t>onpolicy</a:t>
                       </a:r>
                     </a:p>
                   </a:txBody>
@@ -10780,13 +10780,13 @@
                     <a:p>
                       <a:pPr algn="ctr"/>
                       <a:r>
-                        <a:rPr sz="1200" b="0" i="0">
+                        <a:rPr sz="1100" b="0" i="0">
                           <a:solidFill>
                             <a:srgbClr val="222222"/>
                           </a:solidFill>
                           <a:latin typeface="Noto Sans CJK KR"/>
                         </a:rPr>
-                        <a:t>220</a:t>
+                        <a:t>228</a:t>
                       </a:r>
                     </a:p>
                   </a:txBody>
@@ -10803,7 +10803,78 @@
                     <a:p>
                       <a:pPr algn="ctr"/>
                       <a:r>
-                        <a:rPr sz="1200" b="0" i="0">
+                        <a:rPr sz="1100" b="0" i="0">
+                          <a:solidFill>
+                            <a:srgbClr val="222222"/>
+                          </a:solidFill>
+                          <a:latin typeface="Noto Sans CJK KR"/>
+                        </a:rPr>
+                        <a:t>SFT 모델이 실제 생성한 오답 (체인 154 등)</a:t>
+                      </a:r>
+                    </a:p>
+                  </a:txBody>
+                  <a:tcPr marL="73152" marR="54864" marT="27432" marB="27432" anchor="ctr">
+                    <a:solidFill>
+                      <a:srgbClr val="F4F6F8"/>
+                    </a:solidFill>
+                  </a:tcPr>
+                </a:tc>
+              </a:tr>
+              <a:tr h="203200">
+                <a:tc>
+                  <a:txBody>
+                    <a:bodyPr wrap="square"/>
+                    <a:lstStyle/>
+                    <a:p>
+                      <a:pPr algn="l"/>
+                      <a:r>
+                        <a:rPr sz="1100" b="0" i="0">
+                          <a:solidFill>
+                            <a:srgbClr val="222222"/>
+                          </a:solidFill>
+                          <a:latin typeface="Noto Sans CJK KR"/>
+                        </a:rPr>
+                        <a:t>granularity_swap</a:t>
+                      </a:r>
+                    </a:p>
+                  </a:txBody>
+                  <a:tcPr marL="73152" marR="54864" marT="27432" marB="27432" anchor="ctr">
+                    <a:solidFill>
+                      <a:srgbClr val="FFFFFF"/>
+                    </a:solidFill>
+                  </a:tcPr>
+                </a:tc>
+                <a:tc>
+                  <a:txBody>
+                    <a:bodyPr wrap="square"/>
+                    <a:lstStyle/>
+                    <a:p>
+                      <a:pPr algn="ctr"/>
+                      <a:r>
+                        <a:rPr sz="1100" b="0" i="0">
+                          <a:solidFill>
+                            <a:srgbClr val="222222"/>
+                          </a:solidFill>
+                          <a:latin typeface="Noto Sans CJK KR"/>
+                        </a:rPr>
+                        <a:t>220</a:t>
+                      </a:r>
+                    </a:p>
+                  </a:txBody>
+                  <a:tcPr marL="73152" marR="54864" marT="27432" marB="27432" anchor="ctr">
+                    <a:solidFill>
+                      <a:srgbClr val="FFFFFF"/>
+                    </a:solidFill>
+                  </a:tcPr>
+                </a:tc>
+                <a:tc>
+                  <a:txBody>
+                    <a:bodyPr wrap="square"/>
+                    <a:lstStyle/>
+                    <a:p>
+                      <a:pPr algn="ctr"/>
+                      <a:r>
+                        <a:rPr sz="1100" b="0" i="0">
                           <a:solidFill>
                             <a:srgbClr val="222222"/>
                           </a:solidFill>
@@ -10815,12 +10886,12 @@
                   </a:txBody>
                   <a:tcPr marL="73152" marR="54864" marT="27432" marB="27432" anchor="ctr">
                     <a:solidFill>
-                      <a:srgbClr val="F4F6F8"/>
+                      <a:srgbClr val="FFFFFF"/>
                     </a:solidFill>
                   </a:tcPr>
                 </a:tc>
               </a:tr>
-              <a:tr h="289560">
+              <a:tr h="203200">
                 <a:tc>
                   <a:txBody>
                     <a:bodyPr wrap="square"/>
@@ -10828,7 +10899,78 @@
                     <a:p>
                       <a:pPr algn="l"/>
                       <a:r>
-                        <a:rPr sz="1200" b="0" i="0">
+                        <a:rPr sz="1100" b="0" i="0">
+                          <a:solidFill>
+                            <a:srgbClr val="222222"/>
+                          </a:solidFill>
+                          <a:latin typeface="Noto Sans CJK KR"/>
+                        </a:rPr>
+                        <a:t>dependency_scatter</a:t>
+                      </a:r>
+                    </a:p>
+                  </a:txBody>
+                  <a:tcPr marL="73152" marR="54864" marT="27432" marB="27432" anchor="ctr">
+                    <a:solidFill>
+                      <a:srgbClr val="F4F6F8"/>
+                    </a:solidFill>
+                  </a:tcPr>
+                </a:tc>
+                <a:tc>
+                  <a:txBody>
+                    <a:bodyPr wrap="square"/>
+                    <a:lstStyle/>
+                    <a:p>
+                      <a:pPr algn="ctr"/>
+                      <a:r>
+                        <a:rPr sz="1100" b="0" i="0">
+                          <a:solidFill>
+                            <a:srgbClr val="222222"/>
+                          </a:solidFill>
+                          <a:latin typeface="Noto Sans CJK KR"/>
+                        </a:rPr>
+                        <a:t>185</a:t>
+                      </a:r>
+                    </a:p>
+                  </a:txBody>
+                  <a:tcPr marL="73152" marR="54864" marT="27432" marB="27432" anchor="ctr">
+                    <a:solidFill>
+                      <a:srgbClr val="F4F6F8"/>
+                    </a:solidFill>
+                  </a:tcPr>
+                </a:tc>
+                <a:tc>
+                  <a:txBody>
+                    <a:bodyPr wrap="square"/>
+                    <a:lstStyle/>
+                    <a:p>
+                      <a:pPr algn="ctr"/>
+                      <a:r>
+                        <a:rPr sz="1100" b="0" i="0">
+                          <a:solidFill>
+                            <a:srgbClr val="222222"/>
+                          </a:solidFill>
+                          <a:latin typeface="Noto Sans CJK KR"/>
+                        </a:rPr>
+                        <a:t>의존성 체인을 분산 배치</a:t>
+                      </a:r>
+                    </a:p>
+                  </a:txBody>
+                  <a:tcPr marL="73152" marR="54864" marT="27432" marB="27432" anchor="ctr">
+                    <a:solidFill>
+                      <a:srgbClr val="F4F6F8"/>
+                    </a:solidFill>
+                  </a:tcPr>
+                </a:tc>
+              </a:tr>
+              <a:tr h="203200">
+                <a:tc>
+                  <a:txBody>
+                    <a:bodyPr wrap="square"/>
+                    <a:lstStyle/>
+                    <a:p>
+                      <a:pPr algn="l"/>
+                      <a:r>
+                        <a:rPr sz="1100" b="0" i="0">
                           <a:solidFill>
                             <a:srgbClr val="222222"/>
                           </a:solidFill>
@@ -10851,7 +10993,7 @@
                     <a:p>
                       <a:pPr algn="ctr"/>
                       <a:r>
-                        <a:rPr sz="1200" b="0" i="0">
+                        <a:rPr sz="1100" b="0" i="0">
                           <a:solidFill>
                             <a:srgbClr val="222222"/>
                           </a:solidFill>
@@ -10874,7 +11016,7 @@
                     <a:p>
                       <a:pPr algn="ctr"/>
                       <a:r>
-                        <a:rPr sz="1200" b="0" i="0">
+                        <a:rPr sz="1100" b="0" i="0">
                           <a:solidFill>
                             <a:srgbClr val="222222"/>
                           </a:solidFill>
@@ -10891,7 +11033,7 @@
                   </a:tcPr>
                 </a:tc>
               </a:tr>
-              <a:tr h="289560">
+              <a:tr h="203200">
                 <a:tc>
                   <a:txBody>
                     <a:bodyPr wrap="square"/>
@@ -10899,13 +11041,13 @@
                     <a:p>
                       <a:pPr algn="l"/>
                       <a:r>
-                        <a:rPr sz="1200" b="0" i="0">
+                        <a:rPr sz="1100" b="0" i="0">
                           <a:solidFill>
                             <a:srgbClr val="222222"/>
                           </a:solidFill>
                           <a:latin typeface="Noto Sans CJK KR"/>
                         </a:rPr>
-                        <a:t>dependency_scatter</a:t>
+                        <a:t>risk_ignore / past_hallucination</a:t>
                       </a:r>
                     </a:p>
                   </a:txBody>
@@ -10922,13 +11064,13 @@
                     <a:p>
                       <a:pPr algn="ctr"/>
                       <a:r>
-                        <a:rPr sz="1200" b="0" i="0">
+                        <a:rPr sz="1100" b="0" i="0">
                           <a:solidFill>
                             <a:srgbClr val="222222"/>
                           </a:solidFill>
                           <a:latin typeface="Noto Sans CJK KR"/>
                         </a:rPr>
-                        <a:t>185</a:t>
+                        <a:t>92 / 36</a:t>
                       </a:r>
                     </a:p>
                   </a:txBody>
@@ -10945,13 +11087,13 @@
                     <a:p>
                       <a:pPr algn="ctr"/>
                       <a:r>
-                        <a:rPr sz="1200" b="0" i="0">
+                        <a:rPr sz="1100" b="0" i="0">
                           <a:solidFill>
                             <a:srgbClr val="222222"/>
                           </a:solidFill>
                           <a:latin typeface="Noto Sans CJK KR"/>
                         </a:rPr>
-                        <a:t>의존성 체인을 분산 배치</a:t>
+                        <a:t>리스크 미반영 / 지남 단정</a:t>
                       </a:r>
                     </a:p>
                   </a:txBody>
@@ -10962,7 +11104,7 @@
                   </a:tcPr>
                 </a:tc>
               </a:tr>
-              <a:tr h="289560">
+              <a:tr h="203200">
                 <a:tc>
                   <a:txBody>
                     <a:bodyPr wrap="square"/>
@@ -10970,13 +11112,13 @@
                     <a:p>
                       <a:pPr algn="l"/>
                       <a:r>
-                        <a:rPr sz="1200" b="0" i="0">
+                        <a:rPr sz="1100" b="0" i="0">
                           <a:solidFill>
                             <a:srgbClr val="222222"/>
                           </a:solidFill>
                           <a:latin typeface="Noto Sans CJK KR"/>
                         </a:rPr>
-                        <a:t>risk_ignore / past_hallucination</a:t>
+                        <a:t>refusal (거절 쌍)</a:t>
                       </a:r>
                     </a:p>
                   </a:txBody>
@@ -10993,13 +11135,13 @@
                     <a:p>
                       <a:pPr algn="ctr"/>
                       <a:r>
-                        <a:rPr sz="1200" b="0" i="0">
+                        <a:rPr sz="1100" b="0" i="0">
                           <a:solidFill>
                             <a:srgbClr val="222222"/>
                           </a:solidFill>
                           <a:latin typeface="Noto Sans CJK KR"/>
                         </a:rPr>
-                        <a:t>92 / 36</a:t>
+                        <a:t>200</a:t>
                       </a:r>
                     </a:p>
                   </a:txBody>
@@ -11016,19 +11158,90 @@
                     <a:p>
                       <a:pPr algn="ctr"/>
                       <a:r>
-                        <a:rPr sz="1200" b="0" i="0">
+                        <a:rPr sz="1100" b="0" i="0">
                           <a:solidFill>
                             <a:srgbClr val="222222"/>
                           </a:solidFill>
                           <a:latin typeface="Noto Sans CJK KR"/>
                         </a:rPr>
-                        <a:t>리스크 미반영 / 지남 단정</a:t>
+                        <a:t>비일정 입력 거절 학습</a:t>
                       </a:r>
                     </a:p>
                   </a:txBody>
                   <a:tcPr marL="73152" marR="54864" marT="27432" marB="27432" anchor="ctr">
                     <a:solidFill>
                       <a:srgbClr val="FFFFFF"/>
+                    </a:solidFill>
+                  </a:tcPr>
+                </a:tc>
+              </a:tr>
+              <a:tr h="203200">
+                <a:tc>
+                  <a:txBody>
+                    <a:bodyPr wrap="square"/>
+                    <a:lstStyle/>
+                    <a:p>
+                      <a:pPr algn="l"/>
+                      <a:r>
+                        <a:rPr sz="1100" b="0" i="0">
+                          <a:solidFill>
+                            <a:srgbClr val="222222"/>
+                          </a:solidFill>
+                          <a:latin typeface="Noto Sans CJK KR"/>
+                        </a:rPr>
+                        <a:t>합계</a:t>
+                      </a:r>
+                    </a:p>
+                  </a:txBody>
+                  <a:tcPr marL="73152" marR="54864" marT="27432" marB="27432" anchor="ctr">
+                    <a:solidFill>
+                      <a:srgbClr val="F4F6F8"/>
+                    </a:solidFill>
+                  </a:tcPr>
+                </a:tc>
+                <a:tc>
+                  <a:txBody>
+                    <a:bodyPr wrap="square"/>
+                    <a:lstStyle/>
+                    <a:p>
+                      <a:pPr algn="ctr"/>
+                      <a:r>
+                        <a:rPr sz="1100" b="0" i="0">
+                          <a:solidFill>
+                            <a:srgbClr val="222222"/>
+                          </a:solidFill>
+                          <a:latin typeface="Noto Sans CJK KR"/>
+                        </a:rPr>
+                        <a:t>1,368</a:t>
+                      </a:r>
+                    </a:p>
+                  </a:txBody>
+                  <a:tcPr marL="73152" marR="54864" marT="27432" marB="27432" anchor="ctr">
+                    <a:solidFill>
+                      <a:srgbClr val="F4F6F8"/>
+                    </a:solidFill>
+                  </a:tcPr>
+                </a:tc>
+                <a:tc>
+                  <a:txBody>
+                    <a:bodyPr wrap="square"/>
+                    <a:lstStyle/>
+                    <a:p>
+                      <a:pPr algn="ctr"/>
+                      <a:r>
+                        <a:rPr sz="1100" b="0" i="0">
+                          <a:solidFill>
+                            <a:srgbClr val="222222"/>
+                          </a:solidFill>
+                          <a:latin typeface="Noto Sans CJK KR"/>
+                        </a:rPr>
+                        <a:t>—</a:t>
+                      </a:r>
+                    </a:p>
+                  </a:txBody>
+                  <a:tcPr marL="73152" marR="54864" marT="27432" marB="27432" anchor="ctr">
+                    <a:solidFill>
+                      <a:srgbClr val="F4F6F8"/>
                     </a:solidFill>
                   </a:tcPr>
                 </a:tc>

</xml_diff>

<commit_message>
docs: Qwen3.5-9B 검증 결과 통합 — 4B vs 9B 통계 추가
9B는 별도 RTX 4090 서버에서 학습·검증 완료(docker verify_chosen, n=150).
이 머신(RTX 3080 Ti 12GB)엔 어댑터 없어 재검증 불가 → 기존 검증 결과 통합.

Qwen3.5-9B (SFT+DPO v4, n=150): 전체 88.7%
- dated 98% · intraday 97% · risk 95% · relative 93% · chain 57%
- 비-체인 93~98%로 안정화(리스크 80→95%)하나 체인은 57%로 여전히 약점
- 모델 2.3× 키워도 체인 미해결 → SFT 데이터 보강 필요 재확인

- build_9b_chart.py + assets/chart_4b_vs_9b.png (4B vs 9B 비교)
- experiments 인덱스: 9B 실행대기→완료(88.7%), 4B vs 9B 비교표
- README 벤치마크 표에 9B 행 + 비교 차트
- PPT 슬라이드 13(모델 크기 효과) 추가 → 18슬라이드

Co-Authored-By: Claude Opus 4.8 <noreply@anthropic.com>
</commit_message>
<xml_diff>
--- a/presentation/TimeSorter_발표자료.pptx
+++ b/presentation/TimeSorter_발표자료.pptx
@@ -22,6 +22,7 @@
     <p:sldId id="270" r:id="rId21"/>
     <p:sldId id="271" r:id="rId22"/>
     <p:sldId id="272" r:id="rId23"/>
+    <p:sldId id="273" r:id="rId24"/>
   </p:sldIdLst>
   <p:sldSz cx="12191695" cy="6858000" type="screen4x3"/>
   <p:notesSz cx="6858000" cy="9144000"/>
@@ -4167,6 +4168,292 @@
 </file>
 
 <file path=ppt/slides/slide13.xml><?xml version="1.0" encoding="utf-8"?>
+<p:sld xmlns:a="http://schemas.openxmlformats.org/drawingml/2006/main" xmlns:p="http://schemas.openxmlformats.org/presentationml/2006/main" xmlns:r="http://schemas.openxmlformats.org/officeDocument/2006/relationships">
+  <p:cSld>
+    <p:spTree>
+      <p:nvGrpSpPr>
+        <p:cNvPr id="1" name=""/>
+        <p:cNvGrpSpPr/>
+        <p:nvPr/>
+      </p:nvGrpSpPr>
+      <p:grpSpPr/>
+      <p:sp>
+        <p:nvSpPr>
+          <p:cNvPr id="2" name="Rectangle 1"/>
+          <p:cNvSpPr/>
+          <p:nvPr/>
+        </p:nvSpPr>
+        <p:spPr>
+          <a:xfrm>
+            <a:off x="0" y="0"/>
+            <a:ext cx="12191695" cy="1051560"/>
+          </a:xfrm>
+          <a:prstGeom prst="rect">
+            <a:avLst/>
+          </a:prstGeom>
+          <a:solidFill>
+            <a:srgbClr val="1F2D3D"/>
+          </a:solidFill>
+          <a:ln>
+            <a:noFill/>
+          </a:ln>
+          <a:effectLst/>
+        </p:spPr>
+        <p:style>
+          <a:lnRef idx="1">
+            <a:schemeClr val="accent1"/>
+          </a:lnRef>
+          <a:fillRef idx="3">
+            <a:schemeClr val="accent1"/>
+          </a:fillRef>
+          <a:effectRef idx="2">
+            <a:schemeClr val="accent1"/>
+          </a:effectRef>
+          <a:fontRef idx="minor">
+            <a:schemeClr val="lt1"/>
+          </a:fontRef>
+        </p:style>
+        <p:txBody>
+          <a:bodyPr rtlCol="0" anchor="ctr"/>
+          <a:lstStyle/>
+          <a:p>
+            <a:pPr algn="ctr"/>
+          </a:p>
+        </p:txBody>
+      </p:sp>
+      <p:sp>
+        <p:nvSpPr>
+          <p:cNvPr id="3" name="Rectangle 2"/>
+          <p:cNvSpPr/>
+          <p:nvPr/>
+        </p:nvSpPr>
+        <p:spPr>
+          <a:xfrm>
+            <a:off x="0" y="1051560"/>
+            <a:ext cx="12191695" cy="38100"/>
+          </a:xfrm>
+          <a:prstGeom prst="rect">
+            <a:avLst/>
+          </a:prstGeom>
+          <a:solidFill>
+            <a:srgbClr val="DD8452"/>
+          </a:solidFill>
+          <a:ln>
+            <a:noFill/>
+          </a:ln>
+          <a:effectLst/>
+        </p:spPr>
+        <p:style>
+          <a:lnRef idx="1">
+            <a:schemeClr val="accent1"/>
+          </a:lnRef>
+          <a:fillRef idx="3">
+            <a:schemeClr val="accent1"/>
+          </a:fillRef>
+          <a:effectRef idx="2">
+            <a:schemeClr val="accent1"/>
+          </a:effectRef>
+          <a:fontRef idx="minor">
+            <a:schemeClr val="lt1"/>
+          </a:fontRef>
+        </p:style>
+        <p:txBody>
+          <a:bodyPr rtlCol="0" anchor="ctr"/>
+          <a:lstStyle/>
+          <a:p>
+            <a:pPr algn="ctr"/>
+          </a:p>
+        </p:txBody>
+      </p:sp>
+      <p:sp>
+        <p:nvSpPr>
+          <p:cNvPr id="4" name="TextBox 3"/>
+          <p:cNvSpPr txBox="1"/>
+          <p:nvPr/>
+        </p:nvSpPr>
+        <p:spPr>
+          <a:xfrm>
+            <a:off x="457200" y="128016"/>
+            <a:ext cx="10972800" cy="320040"/>
+          </a:xfrm>
+          <a:prstGeom prst="rect">
+            <a:avLst/>
+          </a:prstGeom>
+          <a:noFill/>
+        </p:spPr>
+        <p:txBody>
+          <a:bodyPr wrap="square" anchor="t">
+            <a:spAutoFit/>
+          </a:bodyPr>
+          <a:lstStyle/>
+          <a:p>
+            <a:pPr algn="l"/>
+            <a:r>
+              <a:rPr sz="1200" b="1" i="0">
+                <a:solidFill>
+                  <a:srgbClr val="DD8452"/>
+                </a:solidFill>
+                <a:latin typeface="Noto Sans CJK KR"/>
+              </a:rPr>
+              <a:t>RESULTS</a:t>
+            </a:r>
+          </a:p>
+        </p:txBody>
+      </p:sp>
+      <p:sp>
+        <p:nvSpPr>
+          <p:cNvPr id="5" name="TextBox 4"/>
+          <p:cNvSpPr txBox="1"/>
+          <p:nvPr/>
+        </p:nvSpPr>
+        <p:spPr>
+          <a:xfrm>
+            <a:off x="457200" y="384048"/>
+            <a:ext cx="11247120" cy="594360"/>
+          </a:xfrm>
+          <a:prstGeom prst="rect">
+            <a:avLst/>
+          </a:prstGeom>
+          <a:noFill/>
+        </p:spPr>
+        <p:txBody>
+          <a:bodyPr wrap="square" anchor="t">
+            <a:spAutoFit/>
+          </a:bodyPr>
+          <a:lstStyle/>
+          <a:p>
+            <a:pPr algn="l"/>
+            <a:r>
+              <a:rPr sz="2600" b="1" i="0">
+                <a:solidFill>
+                  <a:srgbClr val="FFFFFF"/>
+                </a:solidFill>
+                <a:latin typeface="Noto Sans CJK KR"/>
+              </a:rPr>
+              <a:t>모델 크기 효과 — Qwen3.5 4B vs 9B</a:t>
+            </a:r>
+          </a:p>
+        </p:txBody>
+      </p:sp>
+      <p:pic>
+        <p:nvPicPr>
+          <p:cNvPr id="6" name="Picture 5" descr="chart_4b_vs_9b.png"/>
+          <p:cNvPicPr>
+            <a:picLocks noChangeAspect="1"/>
+          </p:cNvPicPr>
+          <p:nvPr/>
+        </p:nvPicPr>
+        <p:blipFill>
+          <a:blip r:embed="rId2"/>
+          <a:stretch>
+            <a:fillRect/>
+          </a:stretch>
+        </p:blipFill>
+        <p:spPr>
+          <a:xfrm>
+            <a:off x="1045083" y="1325880"/>
+            <a:ext cx="10117074" cy="4114800"/>
+          </a:xfrm>
+          <a:prstGeom prst="rect">
+            <a:avLst/>
+          </a:prstGeom>
+        </p:spPr>
+      </p:pic>
+      <p:sp>
+        <p:nvSpPr>
+          <p:cNvPr id="7" name="TextBox 6"/>
+          <p:cNvSpPr txBox="1"/>
+          <p:nvPr/>
+        </p:nvSpPr>
+        <p:spPr>
+          <a:xfrm>
+            <a:off x="457200" y="5577840"/>
+            <a:ext cx="11247120" cy="914400"/>
+          </a:xfrm>
+          <a:prstGeom prst="rect">
+            <a:avLst/>
+          </a:prstGeom>
+          <a:noFill/>
+        </p:spPr>
+        <p:txBody>
+          <a:bodyPr wrap="square" anchor="t">
+            <a:spAutoFit/>
+          </a:bodyPr>
+          <a:lstStyle/>
+          <a:p>
+            <a:pPr algn="ctr"/>
+            <a:r>
+              <a:rPr sz="1300" b="1" i="0">
+                <a:solidFill>
+                  <a:srgbClr val="1F2D3D"/>
+                </a:solidFill>
+                <a:latin typeface="Noto Sans CJK KR"/>
+              </a:rPr>
+              <a:t>9B(2.3× 크기, RTX 4090, n=150)은 리스크 80→95% 등 약점을 평준화하나, 의존성 체인은 57%로 여전히 최대 약점</a:t>
+            </a:r>
+          </a:p>
+          <a:p>
+            <a:pPr algn="ctr">
+              <a:spcBef>
+                <a:spcPts val="300"/>
+              </a:spcBef>
+            </a:pPr>
+            <a:r>
+              <a:rPr sz="1100" b="0" i="1">
+                <a:solidFill>
+                  <a:srgbClr val="5A5A5A"/>
+                </a:solidFill>
+                <a:latin typeface="Noto Sans CJK KR"/>
+              </a:rPr>
+              <a:t>→ 체인은 모델 크기가 아니라 SFT 데이터 보강이 필요한 문제 (4B n=30·9B n=150, 표본차 감안)</a:t>
+            </a:r>
+          </a:p>
+        </p:txBody>
+      </p:sp>
+      <p:sp>
+        <p:nvSpPr>
+          <p:cNvPr id="8" name="TextBox 7"/>
+          <p:cNvSpPr txBox="1"/>
+          <p:nvPr/>
+        </p:nvSpPr>
+        <p:spPr>
+          <a:xfrm>
+            <a:off x="10789920" y="6446520"/>
+            <a:ext cx="1280160" cy="320040"/>
+          </a:xfrm>
+          <a:prstGeom prst="rect">
+            <a:avLst/>
+          </a:prstGeom>
+          <a:noFill/>
+        </p:spPr>
+        <p:txBody>
+          <a:bodyPr wrap="square" anchor="t">
+            <a:spAutoFit/>
+          </a:bodyPr>
+          <a:lstStyle/>
+          <a:p>
+            <a:pPr algn="r"/>
+            <a:r>
+              <a:rPr sz="1000" b="0" i="0">
+                <a:solidFill>
+                  <a:srgbClr val="5A5A5A"/>
+                </a:solidFill>
+                <a:latin typeface="Noto Sans CJK KR"/>
+              </a:rPr>
+              <a:t>13</a:t>
+            </a:r>
+          </a:p>
+        </p:txBody>
+      </p:sp>
+    </p:spTree>
+  </p:cSld>
+  <p:clrMapOvr>
+    <a:masterClrMapping/>
+  </p:clrMapOvr>
+</p:sld>
+</file>
+
+<file path=ppt/slides/slide14.xml><?xml version="1.0" encoding="utf-8"?>
 <p:sld xmlns:a="http://schemas.openxmlformats.org/drawingml/2006/main" xmlns:p="http://schemas.openxmlformats.org/presentationml/2006/main" xmlns:r="http://schemas.openxmlformats.org/officeDocument/2006/relationships">
   <p:cSld>
     <p:spTree>
@@ -5074,7 +5361,7 @@
                 </a:solidFill>
                 <a:latin typeface="Noto Sans CJK KR"/>
               </a:rPr>
-              <a:t>13</a:t>
+              <a:t>14</a:t>
             </a:r>
           </a:p>
         </p:txBody>
@@ -5087,7 +5374,7 @@
 </p:sld>
 </file>
 
-<file path=ppt/slides/slide14.xml><?xml version="1.0" encoding="utf-8"?>
+<file path=ppt/slides/slide15.xml><?xml version="1.0" encoding="utf-8"?>
 <p:sld xmlns:a="http://schemas.openxmlformats.org/drawingml/2006/main" xmlns:p="http://schemas.openxmlformats.org/presentationml/2006/main" xmlns:r="http://schemas.openxmlformats.org/officeDocument/2006/relationships">
   <p:cSld>
     <p:spTree>
@@ -5486,7 +5773,7 @@
                 </a:solidFill>
                 <a:latin typeface="Noto Sans CJK KR"/>
               </a:rPr>
-              <a:t>14</a:t>
+              <a:t>15</a:t>
             </a:r>
           </a:p>
         </p:txBody>
@@ -5499,7 +5786,7 @@
 </p:sld>
 </file>
 
-<file path=ppt/slides/slide15.xml><?xml version="1.0" encoding="utf-8"?>
+<file path=ppt/slides/slide16.xml><?xml version="1.0" encoding="utf-8"?>
 <p:sld xmlns:a="http://schemas.openxmlformats.org/drawingml/2006/main" xmlns:p="http://schemas.openxmlformats.org/presentationml/2006/main" xmlns:r="http://schemas.openxmlformats.org/officeDocument/2006/relationships">
   <p:cSld>
     <p:spTree>
@@ -6437,7 +6724,7 @@
                 </a:solidFill>
                 <a:latin typeface="Noto Sans CJK KR"/>
               </a:rPr>
-              <a:t>15</a:t>
+              <a:t>16</a:t>
             </a:r>
           </a:p>
         </p:txBody>
@@ -6450,7 +6737,7 @@
 </p:sld>
 </file>
 
-<file path=ppt/slides/slide16.xml><?xml version="1.0" encoding="utf-8"?>
+<file path=ppt/slides/slide17.xml><?xml version="1.0" encoding="utf-8"?>
 <p:sld xmlns:a="http://schemas.openxmlformats.org/drawingml/2006/main" xmlns:p="http://schemas.openxmlformats.org/presentationml/2006/main" xmlns:r="http://schemas.openxmlformats.org/officeDocument/2006/relationships">
   <p:cSld>
     <p:spTree>
@@ -7138,7 +7425,7 @@
                 </a:solidFill>
                 <a:latin typeface="Noto Sans CJK KR"/>
               </a:rPr>
-              <a:t>16</a:t>
+              <a:t>17</a:t>
             </a:r>
           </a:p>
         </p:txBody>
@@ -7151,7 +7438,7 @@
 </p:sld>
 </file>
 
-<file path=ppt/slides/slide17.xml><?xml version="1.0" encoding="utf-8"?>
+<file path=ppt/slides/slide18.xml><?xml version="1.0" encoding="utf-8"?>
 <p:sld xmlns:a="http://schemas.openxmlformats.org/drawingml/2006/main" xmlns:p="http://schemas.openxmlformats.org/presentationml/2006/main" xmlns:r="http://schemas.openxmlformats.org/officeDocument/2006/relationships">
   <p:cSld>
     <p:spTree>

</xml_diff>

<commit_message>
docs: 9B 4-way 검증 통계 추가 (base/no-sft/SFT/DPO, n=30)
9B 어댑터를 HF(pieroot/TimeSorter-qwen3-lora)에서 받아 RTX 3080 Ti 12GB
4-bit 추론으로 4-way 검증(9B도 12GB에 적재 가능 확인).

Qwen3.5-9B 4-way (n=30, schema/content):
- base(no FT) 3.3%/30.0% · no-adapter 0.0%/46.7% · SFT 93.3% · DPO 93.3%
- 4B와 동일 패턴: no-adapter 0%는 포맷 문제(내용 46.7%), SFT가 고정
- SFT=DPO 완전 동일(체인 4/6 고착) — 9B에서도 DPO가 체인 못 옮김

- build_9b_4way.py + chart_9b_schema_vs_content.png
- benchmark_9b.py로 검증(이전 커밋), 결과 README/실험보고서 통합
- README 벤치마크 표에 9B base/no-sft/SFT/DPO 행 추가
- PPT 슬라이드 14(9B 4-way) 추가 → 19슬라이드

Co-Authored-By: Claude Opus 4.8 <noreply@anthropic.com>
</commit_message>
<xml_diff>
--- a/presentation/TimeSorter_발표자료.pptx
+++ b/presentation/TimeSorter_발표자료.pptx
@@ -23,6 +23,7 @@
     <p:sldId id="271" r:id="rId22"/>
     <p:sldId id="272" r:id="rId23"/>
     <p:sldId id="273" r:id="rId24"/>
+    <p:sldId id="274" r:id="rId25"/>
   </p:sldIdLst>
   <p:sldSz cx="12191695" cy="6858000" type="screen4x3"/>
   <p:notesSz cx="6858000" cy="9144000"/>
@@ -4454,6 +4455,292 @@
 </file>
 
 <file path=ppt/slides/slide14.xml><?xml version="1.0" encoding="utf-8"?>
+<p:sld xmlns:a="http://schemas.openxmlformats.org/drawingml/2006/main" xmlns:p="http://schemas.openxmlformats.org/presentationml/2006/main" xmlns:r="http://schemas.openxmlformats.org/officeDocument/2006/relationships">
+  <p:cSld>
+    <p:spTree>
+      <p:nvGrpSpPr>
+        <p:cNvPr id="1" name=""/>
+        <p:cNvGrpSpPr/>
+        <p:nvPr/>
+      </p:nvGrpSpPr>
+      <p:grpSpPr/>
+      <p:sp>
+        <p:nvSpPr>
+          <p:cNvPr id="2" name="Rectangle 1"/>
+          <p:cNvSpPr/>
+          <p:nvPr/>
+        </p:nvSpPr>
+        <p:spPr>
+          <a:xfrm>
+            <a:off x="0" y="0"/>
+            <a:ext cx="12191695" cy="1051560"/>
+          </a:xfrm>
+          <a:prstGeom prst="rect">
+            <a:avLst/>
+          </a:prstGeom>
+          <a:solidFill>
+            <a:srgbClr val="1F2D3D"/>
+          </a:solidFill>
+          <a:ln>
+            <a:noFill/>
+          </a:ln>
+          <a:effectLst/>
+        </p:spPr>
+        <p:style>
+          <a:lnRef idx="1">
+            <a:schemeClr val="accent1"/>
+          </a:lnRef>
+          <a:fillRef idx="3">
+            <a:schemeClr val="accent1"/>
+          </a:fillRef>
+          <a:effectRef idx="2">
+            <a:schemeClr val="accent1"/>
+          </a:effectRef>
+          <a:fontRef idx="minor">
+            <a:schemeClr val="lt1"/>
+          </a:fontRef>
+        </p:style>
+        <p:txBody>
+          <a:bodyPr rtlCol="0" anchor="ctr"/>
+          <a:lstStyle/>
+          <a:p>
+            <a:pPr algn="ctr"/>
+          </a:p>
+        </p:txBody>
+      </p:sp>
+      <p:sp>
+        <p:nvSpPr>
+          <p:cNvPr id="3" name="Rectangle 2"/>
+          <p:cNvSpPr/>
+          <p:nvPr/>
+        </p:nvSpPr>
+        <p:spPr>
+          <a:xfrm>
+            <a:off x="0" y="1051560"/>
+            <a:ext cx="12191695" cy="38100"/>
+          </a:xfrm>
+          <a:prstGeom prst="rect">
+            <a:avLst/>
+          </a:prstGeom>
+          <a:solidFill>
+            <a:srgbClr val="DD8452"/>
+          </a:solidFill>
+          <a:ln>
+            <a:noFill/>
+          </a:ln>
+          <a:effectLst/>
+        </p:spPr>
+        <p:style>
+          <a:lnRef idx="1">
+            <a:schemeClr val="accent1"/>
+          </a:lnRef>
+          <a:fillRef idx="3">
+            <a:schemeClr val="accent1"/>
+          </a:fillRef>
+          <a:effectRef idx="2">
+            <a:schemeClr val="accent1"/>
+          </a:effectRef>
+          <a:fontRef idx="minor">
+            <a:schemeClr val="lt1"/>
+          </a:fontRef>
+        </p:style>
+        <p:txBody>
+          <a:bodyPr rtlCol="0" anchor="ctr"/>
+          <a:lstStyle/>
+          <a:p>
+            <a:pPr algn="ctr"/>
+          </a:p>
+        </p:txBody>
+      </p:sp>
+      <p:sp>
+        <p:nvSpPr>
+          <p:cNvPr id="4" name="TextBox 3"/>
+          <p:cNvSpPr txBox="1"/>
+          <p:nvPr/>
+        </p:nvSpPr>
+        <p:spPr>
+          <a:xfrm>
+            <a:off x="457200" y="128016"/>
+            <a:ext cx="10972800" cy="320040"/>
+          </a:xfrm>
+          <a:prstGeom prst="rect">
+            <a:avLst/>
+          </a:prstGeom>
+          <a:noFill/>
+        </p:spPr>
+        <p:txBody>
+          <a:bodyPr wrap="square" anchor="t">
+            <a:spAutoFit/>
+          </a:bodyPr>
+          <a:lstStyle/>
+          <a:p>
+            <a:pPr algn="l"/>
+            <a:r>
+              <a:rPr sz="1200" b="1" i="0">
+                <a:solidFill>
+                  <a:srgbClr val="DD8452"/>
+                </a:solidFill>
+                <a:latin typeface="Noto Sans CJK KR"/>
+              </a:rPr>
+              <a:t>RESULTS</a:t>
+            </a:r>
+          </a:p>
+        </p:txBody>
+      </p:sp>
+      <p:sp>
+        <p:nvSpPr>
+          <p:cNvPr id="5" name="TextBox 4"/>
+          <p:cNvSpPr txBox="1"/>
+          <p:nvPr/>
+        </p:nvSpPr>
+        <p:spPr>
+          <a:xfrm>
+            <a:off x="457200" y="384048"/>
+            <a:ext cx="11247120" cy="594360"/>
+          </a:xfrm>
+          <a:prstGeom prst="rect">
+            <a:avLst/>
+          </a:prstGeom>
+          <a:noFill/>
+        </p:spPr>
+        <p:txBody>
+          <a:bodyPr wrap="square" anchor="t">
+            <a:spAutoFit/>
+          </a:bodyPr>
+          <a:lstStyle/>
+          <a:p>
+            <a:pPr algn="l"/>
+            <a:r>
+              <a:rPr sz="2600" b="1" i="0">
+                <a:solidFill>
+                  <a:srgbClr val="FFFFFF"/>
+                </a:solidFill>
+                <a:latin typeface="Noto Sans CJK KR"/>
+              </a:rPr>
+              <a:t>Qwen3.5-9B 4-way — 포맷 vs 추론 (n=30)</a:t>
+            </a:r>
+          </a:p>
+        </p:txBody>
+      </p:sp>
+      <p:pic>
+        <p:nvPicPr>
+          <p:cNvPr id="6" name="Picture 5" descr="chart_9b_schema_vs_content.png"/>
+          <p:cNvPicPr>
+            <a:picLocks noChangeAspect="1"/>
+          </p:cNvPicPr>
+          <p:nvPr/>
+        </p:nvPicPr>
+        <p:blipFill>
+          <a:blip r:embed="rId2"/>
+          <a:stretch>
+            <a:fillRect/>
+          </a:stretch>
+        </p:blipFill>
+        <p:spPr>
+          <a:xfrm>
+            <a:off x="2175151" y="1325880"/>
+            <a:ext cx="7856938" cy="4206240"/>
+          </a:xfrm>
+          <a:prstGeom prst="rect">
+            <a:avLst/>
+          </a:prstGeom>
+        </p:spPr>
+      </p:pic>
+      <p:sp>
+        <p:nvSpPr>
+          <p:cNvPr id="7" name="TextBox 6"/>
+          <p:cNvSpPr txBox="1"/>
+          <p:nvPr/>
+        </p:nvSpPr>
+        <p:spPr>
+          <a:xfrm>
+            <a:off x="457200" y="5669280"/>
+            <a:ext cx="11247120" cy="822960"/>
+          </a:xfrm>
+          <a:prstGeom prst="rect">
+            <a:avLst/>
+          </a:prstGeom>
+          <a:noFill/>
+        </p:spPr>
+        <p:txBody>
+          <a:bodyPr wrap="square" anchor="t">
+            <a:spAutoFit/>
+          </a:bodyPr>
+          <a:lstStyle/>
+          <a:p>
+            <a:pPr algn="ctr"/>
+            <a:r>
+              <a:rPr sz="1300" b="1" i="0">
+                <a:solidFill>
+                  <a:srgbClr val="1F2D3D"/>
+                </a:solidFill>
+                <a:latin typeface="Noto Sans CJK KR"/>
+              </a:rPr>
+              <a:t>9B도 4B와 동일 패턴 — no-adapter 스키마 0%지만 내용 46.7%(포맷만 미준수), SFT가 93.3%로 고정</a:t>
+            </a:r>
+          </a:p>
+          <a:p>
+            <a:pPr algn="ctr">
+              <a:spcBef>
+                <a:spcPts val="300"/>
+              </a:spcBef>
+            </a:pPr>
+            <a:r>
+              <a:rPr sz="1100" b="0" i="1">
+                <a:solidFill>
+                  <a:srgbClr val="5A5A5A"/>
+                </a:solidFill>
+                <a:latin typeface="Noto Sans CJK KR"/>
+              </a:rPr>
+              <a:t>SFT=DPO 완전 동일(체인 4/6 고착) — 9B에서도 DPO가 체인을 못 옮김</a:t>
+            </a:r>
+          </a:p>
+        </p:txBody>
+      </p:sp>
+      <p:sp>
+        <p:nvSpPr>
+          <p:cNvPr id="8" name="TextBox 7"/>
+          <p:cNvSpPr txBox="1"/>
+          <p:nvPr/>
+        </p:nvSpPr>
+        <p:spPr>
+          <a:xfrm>
+            <a:off x="10789920" y="6446520"/>
+            <a:ext cx="1280160" cy="320040"/>
+          </a:xfrm>
+          <a:prstGeom prst="rect">
+            <a:avLst/>
+          </a:prstGeom>
+          <a:noFill/>
+        </p:spPr>
+        <p:txBody>
+          <a:bodyPr wrap="square" anchor="t">
+            <a:spAutoFit/>
+          </a:bodyPr>
+          <a:lstStyle/>
+          <a:p>
+            <a:pPr algn="r"/>
+            <a:r>
+              <a:rPr sz="1000" b="0" i="0">
+                <a:solidFill>
+                  <a:srgbClr val="5A5A5A"/>
+                </a:solidFill>
+                <a:latin typeface="Noto Sans CJK KR"/>
+              </a:rPr>
+              <a:t>14</a:t>
+            </a:r>
+          </a:p>
+        </p:txBody>
+      </p:sp>
+    </p:spTree>
+  </p:cSld>
+  <p:clrMapOvr>
+    <a:masterClrMapping/>
+  </p:clrMapOvr>
+</p:sld>
+</file>
+
+<file path=ppt/slides/slide15.xml><?xml version="1.0" encoding="utf-8"?>
 <p:sld xmlns:a="http://schemas.openxmlformats.org/drawingml/2006/main" xmlns:p="http://schemas.openxmlformats.org/presentationml/2006/main" xmlns:r="http://schemas.openxmlformats.org/officeDocument/2006/relationships">
   <p:cSld>
     <p:spTree>
@@ -5361,7 +5648,7 @@
                 </a:solidFill>
                 <a:latin typeface="Noto Sans CJK KR"/>
               </a:rPr>
-              <a:t>14</a:t>
+              <a:t>15</a:t>
             </a:r>
           </a:p>
         </p:txBody>
@@ -5374,7 +5661,7 @@
 </p:sld>
 </file>
 
-<file path=ppt/slides/slide15.xml><?xml version="1.0" encoding="utf-8"?>
+<file path=ppt/slides/slide16.xml><?xml version="1.0" encoding="utf-8"?>
 <p:sld xmlns:a="http://schemas.openxmlformats.org/drawingml/2006/main" xmlns:p="http://schemas.openxmlformats.org/presentationml/2006/main" xmlns:r="http://schemas.openxmlformats.org/officeDocument/2006/relationships">
   <p:cSld>
     <p:spTree>
@@ -5773,7 +6060,7 @@
                 </a:solidFill>
                 <a:latin typeface="Noto Sans CJK KR"/>
               </a:rPr>
-              <a:t>15</a:t>
+              <a:t>16</a:t>
             </a:r>
           </a:p>
         </p:txBody>
@@ -5786,7 +6073,7 @@
 </p:sld>
 </file>
 
-<file path=ppt/slides/slide16.xml><?xml version="1.0" encoding="utf-8"?>
+<file path=ppt/slides/slide17.xml><?xml version="1.0" encoding="utf-8"?>
 <p:sld xmlns:a="http://schemas.openxmlformats.org/drawingml/2006/main" xmlns:p="http://schemas.openxmlformats.org/presentationml/2006/main" xmlns:r="http://schemas.openxmlformats.org/officeDocument/2006/relationships">
   <p:cSld>
     <p:spTree>
@@ -6724,7 +7011,7 @@
                 </a:solidFill>
                 <a:latin typeface="Noto Sans CJK KR"/>
               </a:rPr>
-              <a:t>16</a:t>
+              <a:t>17</a:t>
             </a:r>
           </a:p>
         </p:txBody>
@@ -6737,7 +7024,7 @@
 </p:sld>
 </file>
 
-<file path=ppt/slides/slide17.xml><?xml version="1.0" encoding="utf-8"?>
+<file path=ppt/slides/slide18.xml><?xml version="1.0" encoding="utf-8"?>
 <p:sld xmlns:a="http://schemas.openxmlformats.org/drawingml/2006/main" xmlns:p="http://schemas.openxmlformats.org/presentationml/2006/main" xmlns:r="http://schemas.openxmlformats.org/officeDocument/2006/relationships">
   <p:cSld>
     <p:spTree>
@@ -7425,7 +7712,7 @@
                 </a:solidFill>
                 <a:latin typeface="Noto Sans CJK KR"/>
               </a:rPr>
-              <a:t>17</a:t>
+              <a:t>18</a:t>
             </a:r>
           </a:p>
         </p:txBody>
@@ -7438,7 +7725,7 @@
 </p:sld>
 </file>
 
-<file path=ppt/slides/slide18.xml><?xml version="1.0" encoding="utf-8"?>
+<file path=ppt/slides/slide19.xml><?xml version="1.0" encoding="utf-8"?>
 <p:sld xmlns:a="http://schemas.openxmlformats.org/drawingml/2006/main" xmlns:p="http://schemas.openxmlformats.org/presentationml/2006/main" xmlns:r="http://schemas.openxmlformats.org/officeDocument/2006/relationships">
   <p:cSld>
     <p:spTree>

</xml_diff>